<commit_message>
Add hybrid title/closing treatment inspired by Canva's photo panels
Canva's generated candidates all used real wine-bar stock photography
for a split-panel title slide, which looked good but isn't ours to
reuse (Canva's licensed images, not the user's). Recreated the same
structural idea natively instead: a darker side panel holding an
original line-art wine glass icon, bubble accents, and a concentric-
arc corner flourish, all in the existing wine/gold palette. Applied
lightly to the closing slide too for bookending. Data slides
untouched.
</commit_message>
<xml_diff>
--- a/presentation/Cellar_V_Data_Story.pptx
+++ b/presentation/Cellar_V_Data_Story.pptx
@@ -1909,14 +1909,276 @@
       </p:sp>
       <p:sp>
         <p:nvSpPr>
-          <p:cNvPr id="3" name="Text 1"/>
+          <p:cNvPr id="3" name="Shape 1"/>
+          <p:cNvSpPr/>
+          <p:nvPr/>
+        </p:nvSpPr>
+        <p:spPr>
+          <a:xfrm>
+            <a:off x="8138160" y="0"/>
+            <a:ext cx="4053535" cy="6858000"/>
+          </a:xfrm>
+          <a:prstGeom prst="rect">
+            <a:avLst/>
+          </a:prstGeom>
+          <a:solidFill>
+            <a:srgbClr val="471421"/>
+          </a:solidFill>
+          <a:ln/>
+        </p:spPr>
+      </p:sp>
+      <p:sp>
+        <p:nvSpPr>
+          <p:cNvPr id="4" name="Shape 2"/>
+          <p:cNvSpPr/>
+          <p:nvPr/>
+        </p:nvSpPr>
+        <p:spPr>
+          <a:xfrm>
+            <a:off x="10911535" y="-1280160"/>
+            <a:ext cx="2560320" cy="2560320"/>
+          </a:xfrm>
+          <a:prstGeom prst="ellipse">
+            <a:avLst/>
+          </a:prstGeom>
+          <a:ln w="12700">
+            <a:solidFill>
+              <a:srgbClr val="E3B96B">
+                <a:alpha val="45000"/>
+              </a:srgbClr>
+            </a:solidFill>
+            <a:prstDash val="solid"/>
+          </a:ln>
+        </p:spPr>
+      </p:sp>
+      <p:sp>
+        <p:nvSpPr>
+          <p:cNvPr id="5" name="Shape 3"/>
+          <p:cNvSpPr/>
+          <p:nvPr/>
+        </p:nvSpPr>
+        <p:spPr>
+          <a:xfrm>
+            <a:off x="10362895" y="-1828800"/>
+            <a:ext cx="3657600" cy="3657600"/>
+          </a:xfrm>
+          <a:prstGeom prst="ellipse">
+            <a:avLst/>
+          </a:prstGeom>
+          <a:ln w="12700">
+            <a:solidFill>
+              <a:srgbClr val="E3B96B">
+                <a:alpha val="33000"/>
+              </a:srgbClr>
+            </a:solidFill>
+            <a:prstDash val="solid"/>
+          </a:ln>
+        </p:spPr>
+      </p:sp>
+      <p:sp>
+        <p:nvSpPr>
+          <p:cNvPr id="6" name="Shape 4"/>
+          <p:cNvSpPr/>
+          <p:nvPr/>
+        </p:nvSpPr>
+        <p:spPr>
+          <a:xfrm>
+            <a:off x="9814255" y="-2377440"/>
+            <a:ext cx="4754880" cy="4754880"/>
+          </a:xfrm>
+          <a:prstGeom prst="ellipse">
+            <a:avLst/>
+          </a:prstGeom>
+          <a:ln w="12700">
+            <a:solidFill>
+              <a:srgbClr val="E3B96B">
+                <a:alpha val="21000"/>
+              </a:srgbClr>
+            </a:solidFill>
+            <a:prstDash val="solid"/>
+          </a:ln>
+        </p:spPr>
+      </p:sp>
+      <p:sp>
+        <p:nvSpPr>
+          <p:cNvPr id="7" name="Shape 5"/>
+          <p:cNvSpPr/>
+          <p:nvPr/>
+        </p:nvSpPr>
+        <p:spPr>
+          <a:xfrm flipV="1">
+            <a:off x="9479128" y="2331720"/>
+            <a:ext cx="1371600" cy="1440180"/>
+          </a:xfrm>
+          <a:prstGeom prst="triangle">
+            <a:avLst/>
+          </a:prstGeom>
+          <a:solidFill>
+            <a:srgbClr val="E3B96B"/>
+          </a:solidFill>
+          <a:ln/>
+        </p:spPr>
+      </p:sp>
+      <p:sp>
+        <p:nvSpPr>
+          <p:cNvPr id="8" name="Shape 6"/>
+          <p:cNvSpPr/>
+          <p:nvPr/>
+        </p:nvSpPr>
+        <p:spPr>
+          <a:xfrm>
+            <a:off x="10116922" y="3771900"/>
+            <a:ext cx="96012" cy="1303020"/>
+          </a:xfrm>
+          <a:prstGeom prst="rect">
+            <a:avLst/>
+          </a:prstGeom>
+          <a:solidFill>
+            <a:srgbClr val="E3B96B"/>
+          </a:solidFill>
+          <a:ln/>
+        </p:spPr>
+      </p:sp>
+      <p:sp>
+        <p:nvSpPr>
+          <p:cNvPr id="9" name="Shape 7"/>
+          <p:cNvSpPr/>
+          <p:nvPr/>
+        </p:nvSpPr>
+        <p:spPr>
+          <a:xfrm>
+            <a:off x="9719158" y="5006340"/>
+            <a:ext cx="891540" cy="137160"/>
+          </a:xfrm>
+          <a:prstGeom prst="ellipse">
+            <a:avLst/>
+          </a:prstGeom>
+          <a:solidFill>
+            <a:srgbClr val="E3B96B"/>
+          </a:solidFill>
+          <a:ln/>
+        </p:spPr>
+      </p:sp>
+      <p:sp>
+        <p:nvSpPr>
+          <p:cNvPr id="10" name="Shape 8"/>
+          <p:cNvSpPr/>
+          <p:nvPr/>
+        </p:nvSpPr>
+        <p:spPr>
+          <a:xfrm>
+            <a:off x="9616288" y="1965960"/>
+            <a:ext cx="91440" cy="91440"/>
+          </a:xfrm>
+          <a:prstGeom prst="ellipse">
+            <a:avLst/>
+          </a:prstGeom>
+          <a:solidFill>
+            <a:srgbClr val="E3B96B">
+              <a:alpha val="80000"/>
+            </a:srgbClr>
+          </a:solidFill>
+          <a:ln/>
+        </p:spPr>
+      </p:sp>
+      <p:sp>
+        <p:nvSpPr>
+          <p:cNvPr id="11" name="Shape 9"/>
+          <p:cNvSpPr/>
+          <p:nvPr/>
+        </p:nvSpPr>
+        <p:spPr>
+          <a:xfrm>
+            <a:off x="10498684" y="1796796"/>
+            <a:ext cx="64008" cy="64008"/>
+          </a:xfrm>
+          <a:prstGeom prst="ellipse">
+            <a:avLst/>
+          </a:prstGeom>
+          <a:solidFill>
+            <a:srgbClr val="E3B96B">
+              <a:alpha val="65000"/>
+            </a:srgbClr>
+          </a:solidFill>
+          <a:ln/>
+        </p:spPr>
+      </p:sp>
+      <p:sp>
+        <p:nvSpPr>
+          <p:cNvPr id="12" name="Shape 10"/>
+          <p:cNvSpPr/>
+          <p:nvPr/>
+        </p:nvSpPr>
+        <p:spPr>
+          <a:xfrm>
+            <a:off x="10215220" y="1559052"/>
+            <a:ext cx="82296" cy="82296"/>
+          </a:xfrm>
+          <a:prstGeom prst="ellipse">
+            <a:avLst/>
+          </a:prstGeom>
+          <a:solidFill>
+            <a:srgbClr val="E3B96B">
+              <a:alpha val="85000"/>
+            </a:srgbClr>
+          </a:solidFill>
+          <a:ln/>
+        </p:spPr>
+      </p:sp>
+      <p:sp>
+        <p:nvSpPr>
+          <p:cNvPr id="13" name="Shape 11"/>
+          <p:cNvSpPr/>
+          <p:nvPr/>
+        </p:nvSpPr>
+        <p:spPr>
+          <a:xfrm>
+            <a:off x="9908896" y="1435608"/>
+            <a:ext cx="54864" cy="54864"/>
+          </a:xfrm>
+          <a:prstGeom prst="ellipse">
+            <a:avLst/>
+          </a:prstGeom>
+          <a:solidFill>
+            <a:srgbClr val="E3B96B">
+              <a:alpha val="60000"/>
+            </a:srgbClr>
+          </a:solidFill>
+          <a:ln/>
+        </p:spPr>
+      </p:sp>
+      <p:sp>
+        <p:nvSpPr>
+          <p:cNvPr id="14" name="Shape 12"/>
+          <p:cNvSpPr/>
+          <p:nvPr/>
+        </p:nvSpPr>
+        <p:spPr>
+          <a:xfrm>
+            <a:off x="10686136" y="2167128"/>
+            <a:ext cx="54864" cy="54864"/>
+          </a:xfrm>
+          <a:prstGeom prst="ellipse">
+            <a:avLst/>
+          </a:prstGeom>
+          <a:solidFill>
+            <a:srgbClr val="E3B96B">
+              <a:alpha val="55000"/>
+            </a:srgbClr>
+          </a:solidFill>
+          <a:ln/>
+        </p:spPr>
+      </p:sp>
+      <p:sp>
+        <p:nvSpPr>
+          <p:cNvPr id="15" name="Text 13"/>
           <p:cNvSpPr/>
           <p:nvPr/>
         </p:nvSpPr>
         <p:spPr>
           <a:xfrm>
             <a:off x="457200" y="914400"/>
-            <a:ext cx="9144000" cy="365760"/>
+            <a:ext cx="7406640" cy="365760"/>
           </a:xfrm>
           <a:prstGeom prst="rect">
             <a:avLst/>
@@ -1948,14 +2210,14 @@
       </p:sp>
       <p:sp>
         <p:nvSpPr>
-          <p:cNvPr id="4" name="Text 2"/>
+          <p:cNvPr id="16" name="Text 14"/>
           <p:cNvSpPr/>
           <p:nvPr/>
         </p:nvSpPr>
         <p:spPr>
           <a:xfrm>
             <a:off x="457200" y="1371600"/>
-            <a:ext cx="10515600" cy="2377440"/>
+            <a:ext cx="7406640" cy="2560320"/>
           </a:xfrm>
           <a:prstGeom prst="rect">
             <a:avLst/>
@@ -1974,7 +2236,7 @@
               <a:buNone/>
             </a:pPr>
             <a:r>
-              <a:rPr lang="en-US" sz="4800" b="1" dirty="0">
+              <a:rPr lang="en-US" sz="4400" b="1" dirty="0">
                 <a:solidFill>
                   <a:srgbClr val="FFFFFF"/>
                 </a:solidFill>
@@ -1992,7 +2254,7 @@
               <a:buNone/>
             </a:pPr>
             <a:r>
-              <a:rPr lang="en-US" sz="4800" b="1" dirty="0">
+              <a:rPr lang="en-US" sz="4400" b="1" dirty="0">
                 <a:solidFill>
                   <a:srgbClr val="E3B96B"/>
                 </a:solidFill>
@@ -2000,22 +2262,42 @@
                 <a:ea typeface="Cambria" pitchFamily="34" charset="-122"/>
                 <a:cs typeface="Cambria" pitchFamily="34" charset="-120"/>
               </a:rPr>
-              <a:t>Where Should the Next Dollar Go?</a:t>
-            </a:r>
-            <a:endParaRPr lang="en-US" sz="4800" dirty="0"/>
-          </a:p>
-        </p:txBody>
-      </p:sp>
-      <p:sp>
-        <p:nvSpPr>
-          <p:cNvPr id="5" name="Text 3"/>
-          <p:cNvSpPr/>
-          <p:nvPr/>
-        </p:nvSpPr>
-        <p:spPr>
-          <a:xfrm>
-            <a:off x="457200" y="3794760"/>
-            <a:ext cx="8686800" cy="822960"/>
+              <a:t>Where Should the</a:t>
+            </a:r>
+            <a:endParaRPr lang="en-US" sz="4400" dirty="0"/>
+          </a:p>
+          <a:p>
+            <a:pPr indent="0" marL="0">
+              <a:lnSpc>
+                <a:spcPct val="105000"/>
+              </a:lnSpc>
+              <a:buNone/>
+            </a:pPr>
+            <a:r>
+              <a:rPr lang="en-US" sz="4400" b="1" dirty="0">
+                <a:solidFill>
+                  <a:srgbClr val="E3B96B"/>
+                </a:solidFill>
+                <a:latin typeface="Cambria" pitchFamily="34" charset="0"/>
+                <a:ea typeface="Cambria" pitchFamily="34" charset="-122"/>
+                <a:cs typeface="Cambria" pitchFamily="34" charset="-120"/>
+              </a:rPr>
+              <a:t>Next Dollar Go?</a:t>
+            </a:r>
+            <a:endParaRPr lang="en-US" sz="4400" dirty="0"/>
+          </a:p>
+        </p:txBody>
+      </p:sp>
+      <p:sp>
+        <p:nvSpPr>
+          <p:cNvPr id="17" name="Text 15"/>
+          <p:cNvSpPr/>
+          <p:nvPr/>
+        </p:nvSpPr>
+        <p:spPr>
+          <a:xfrm>
+            <a:off x="457200" y="4069080"/>
+            <a:ext cx="7406640" cy="822960"/>
           </a:xfrm>
           <a:prstGeom prst="rect">
             <a:avLst/>
@@ -2034,7 +2316,7 @@
               <a:buNone/>
             </a:pPr>
             <a:r>
-              <a:rPr lang="en-US" sz="1500" dirty="0">
+              <a:rPr lang="en-US" sz="1400" dirty="0">
                 <a:solidFill>
                   <a:srgbClr val="E7DCD5"/>
                 </a:solidFill>
@@ -2044,19 +2326,19 @@
               </a:rPr>
               <a:t>A data story built on 19 months of point-of-sale history (2025 through 2026 year-to-date) and Cellar V's Shopify store — presented as the Analytics App project.</a:t>
             </a:r>
-            <a:endParaRPr lang="en-US" sz="1500" dirty="0"/>
-          </a:p>
-        </p:txBody>
-      </p:sp>
-      <p:sp>
-        <p:nvSpPr>
-          <p:cNvPr id="6" name="Shape 4"/>
-          <p:cNvSpPr/>
-          <p:nvPr/>
-        </p:nvSpPr>
-        <p:spPr>
-          <a:xfrm>
-            <a:off x="457200" y="4892040"/>
+            <a:endParaRPr lang="en-US" sz="1400" dirty="0"/>
+          </a:p>
+        </p:txBody>
+      </p:sp>
+      <p:sp>
+        <p:nvSpPr>
+          <p:cNvPr id="18" name="Shape 16"/>
+          <p:cNvSpPr/>
+          <p:nvPr/>
+        </p:nvSpPr>
+        <p:spPr>
+          <a:xfrm>
+            <a:off x="457200" y="5029200"/>
             <a:ext cx="2743200" cy="0"/>
           </a:xfrm>
           <a:prstGeom prst="line">
@@ -2073,14 +2355,14 @@
       </p:sp>
       <p:sp>
         <p:nvSpPr>
-          <p:cNvPr id="7" name="Text 5"/>
-          <p:cNvSpPr/>
-          <p:nvPr/>
-        </p:nvSpPr>
-        <p:spPr>
-          <a:xfrm>
-            <a:off x="457200" y="5074920"/>
-            <a:ext cx="7315200" cy="365760"/>
+          <p:cNvPr id="19" name="Text 17"/>
+          <p:cNvSpPr/>
+          <p:nvPr/>
+        </p:nvSpPr>
+        <p:spPr>
+          <a:xfrm>
+            <a:off x="457200" y="5193792"/>
+            <a:ext cx="7406640" cy="365760"/>
           </a:xfrm>
           <a:prstGeom prst="rect">
             <a:avLst/>
@@ -2112,14 +2394,14 @@
       </p:sp>
       <p:sp>
         <p:nvSpPr>
-          <p:cNvPr id="8" name="Text 6"/>
-          <p:cNvSpPr/>
-          <p:nvPr/>
-        </p:nvSpPr>
-        <p:spPr>
-          <a:xfrm>
-            <a:off x="457200" y="5413248"/>
-            <a:ext cx="7315200" cy="320040"/>
+          <p:cNvPr id="20" name="Text 18"/>
+          <p:cNvSpPr/>
+          <p:nvPr/>
+        </p:nvSpPr>
+        <p:spPr>
+          <a:xfrm>
+            <a:off x="457200" y="5532120"/>
+            <a:ext cx="7406640" cy="320040"/>
           </a:xfrm>
           <a:prstGeom prst="rect">
             <a:avLst/>
@@ -2151,14 +2433,14 @@
       </p:sp>
       <p:sp>
         <p:nvSpPr>
-          <p:cNvPr id="9" name="Text 7"/>
+          <p:cNvPr id="21" name="Text 19"/>
           <p:cNvSpPr/>
           <p:nvPr/>
         </p:nvSpPr>
         <p:spPr>
           <a:xfrm>
             <a:off x="457200" y="6217920"/>
-            <a:ext cx="7315200" cy="320040"/>
+            <a:ext cx="7406640" cy="320040"/>
           </a:xfrm>
           <a:prstGeom prst="rect">
             <a:avLst/>
@@ -3719,7 +4001,145 @@
       </p:sp>
       <p:sp>
         <p:nvSpPr>
-          <p:cNvPr id="3" name="Text 1"/>
+          <p:cNvPr id="3" name="Shape 1"/>
+          <p:cNvSpPr/>
+          <p:nvPr/>
+        </p:nvSpPr>
+        <p:spPr>
+          <a:xfrm>
+            <a:off x="10911535" y="5577840"/>
+            <a:ext cx="2560320" cy="2560320"/>
+          </a:xfrm>
+          <a:prstGeom prst="ellipse">
+            <a:avLst/>
+          </a:prstGeom>
+          <a:ln w="12700">
+            <a:solidFill>
+              <a:srgbClr val="E3B96B">
+                <a:alpha val="45000"/>
+              </a:srgbClr>
+            </a:solidFill>
+            <a:prstDash val="solid"/>
+          </a:ln>
+        </p:spPr>
+      </p:sp>
+      <p:sp>
+        <p:nvSpPr>
+          <p:cNvPr id="4" name="Shape 2"/>
+          <p:cNvSpPr/>
+          <p:nvPr/>
+        </p:nvSpPr>
+        <p:spPr>
+          <a:xfrm>
+            <a:off x="10362895" y="5029200"/>
+            <a:ext cx="3657600" cy="3657600"/>
+          </a:xfrm>
+          <a:prstGeom prst="ellipse">
+            <a:avLst/>
+          </a:prstGeom>
+          <a:ln w="12700">
+            <a:solidFill>
+              <a:srgbClr val="E3B96B">
+                <a:alpha val="33000"/>
+              </a:srgbClr>
+            </a:solidFill>
+            <a:prstDash val="solid"/>
+          </a:ln>
+        </p:spPr>
+      </p:sp>
+      <p:sp>
+        <p:nvSpPr>
+          <p:cNvPr id="5" name="Shape 3"/>
+          <p:cNvSpPr/>
+          <p:nvPr/>
+        </p:nvSpPr>
+        <p:spPr>
+          <a:xfrm>
+            <a:off x="9814255" y="4480560"/>
+            <a:ext cx="4754880" cy="4754880"/>
+          </a:xfrm>
+          <a:prstGeom prst="ellipse">
+            <a:avLst/>
+          </a:prstGeom>
+          <a:ln w="12700">
+            <a:solidFill>
+              <a:srgbClr val="E3B96B">
+                <a:alpha val="21000"/>
+              </a:srgbClr>
+            </a:solidFill>
+            <a:prstDash val="solid"/>
+          </a:ln>
+        </p:spPr>
+      </p:sp>
+      <p:sp>
+        <p:nvSpPr>
+          <p:cNvPr id="6" name="Shape 4"/>
+          <p:cNvSpPr/>
+          <p:nvPr/>
+        </p:nvSpPr>
+        <p:spPr>
+          <a:xfrm flipV="1">
+            <a:off x="10454335" y="914400"/>
+            <a:ext cx="777240" cy="816102"/>
+          </a:xfrm>
+          <a:prstGeom prst="triangle">
+            <a:avLst/>
+          </a:prstGeom>
+          <a:solidFill>
+            <a:srgbClr val="E3B96B">
+              <a:alpha val="75000"/>
+            </a:srgbClr>
+          </a:solidFill>
+          <a:ln/>
+        </p:spPr>
+      </p:sp>
+      <p:sp>
+        <p:nvSpPr>
+          <p:cNvPr id="7" name="Shape 5"/>
+          <p:cNvSpPr/>
+          <p:nvPr/>
+        </p:nvSpPr>
+        <p:spPr>
+          <a:xfrm>
+            <a:off x="10815752" y="1730502"/>
+            <a:ext cx="54407" cy="738378"/>
+          </a:xfrm>
+          <a:prstGeom prst="rect">
+            <a:avLst/>
+          </a:prstGeom>
+          <a:solidFill>
+            <a:srgbClr val="E3B96B">
+              <a:alpha val="75000"/>
+            </a:srgbClr>
+          </a:solidFill>
+          <a:ln/>
+        </p:spPr>
+      </p:sp>
+      <p:sp>
+        <p:nvSpPr>
+          <p:cNvPr id="8" name="Shape 6"/>
+          <p:cNvSpPr/>
+          <p:nvPr/>
+        </p:nvSpPr>
+        <p:spPr>
+          <a:xfrm>
+            <a:off x="10590352" y="2430018"/>
+            <a:ext cx="505206" cy="77724"/>
+          </a:xfrm>
+          <a:prstGeom prst="ellipse">
+            <a:avLst/>
+          </a:prstGeom>
+          <a:solidFill>
+            <a:srgbClr val="E3B96B">
+              <a:alpha val="75000"/>
+            </a:srgbClr>
+          </a:solidFill>
+          <a:ln/>
+        </p:spPr>
+      </p:sp>
+      <p:sp>
+        <p:nvSpPr>
+          <p:cNvPr id="9" name="Text 7"/>
           <p:cNvSpPr/>
           <p:nvPr/>
         </p:nvSpPr>
@@ -3781,7 +4201,7 @@
       </p:sp>
       <p:sp>
         <p:nvSpPr>
-          <p:cNvPr id="4" name="Text 2"/>
+          <p:cNvPr id="10" name="Text 8"/>
           <p:cNvSpPr/>
           <p:nvPr/>
         </p:nvSpPr>
@@ -3823,7 +4243,7 @@
       </p:sp>
       <p:sp>
         <p:nvSpPr>
-          <p:cNvPr id="5" name="Shape 3"/>
+          <p:cNvPr id="11" name="Shape 9"/>
           <p:cNvSpPr/>
           <p:nvPr/>
         </p:nvSpPr>
@@ -3846,7 +4266,7 @@
       </p:sp>
       <p:sp>
         <p:nvSpPr>
-          <p:cNvPr id="6" name="Text 4"/>
+          <p:cNvPr id="12" name="Text 10"/>
           <p:cNvSpPr/>
           <p:nvPr/>
         </p:nvSpPr>
@@ -3885,7 +4305,7 @@
       </p:sp>
       <p:sp>
         <p:nvSpPr>
-          <p:cNvPr id="7" name="Text 5"/>
+          <p:cNvPr id="13" name="Text 11"/>
           <p:cNvSpPr/>
           <p:nvPr/>
         </p:nvSpPr>

</xml_diff>